<commit_message>
Add real background map to slide 6 of lecture deck
Replace placeholder image with CartoDB Positron basemap showing
all 25 Zurich counting stations plotted on an OSM-based background.

Co-Authored-By: Claude Sonnet 4.6 <noreply@anthropic.com>
</commit_message>
<xml_diff>
--- a/10_Urban_Activity_Analysis/Spatiotemporal_Urban_Activity_Patterns.pptx
+++ b/10_Urban_Activity_Analysis/Spatiotemporal_Urban_Activity_Patterns.pptx
@@ -2113,7 +2113,7 @@
           </a:prstGeom>
           <a:extLst>
             <a:ext uri="{C572A759-6A51-4108-AA02-DFA0A04FC94B}">
-              <ma14:wrappingTextBoxFlag xmlns:ma14="http://schemas.microsoft.com/office/mac/drawingml/2011/main" xmlns="" val="0"/>
+              <ma14:wrappingTextBoxFlag xmlns="" xmlns:ma14="http://schemas.microsoft.com/office/mac/drawingml/2011/main" val="0"/>
             </a:ext>
           </a:extLst>
         </p:spPr>
@@ -2224,7 +2224,7 @@
           </a:prstGeom>
           <a:extLst>
             <a:ext uri="{C572A759-6A51-4108-AA02-DFA0A04FC94B}">
-              <ma14:wrappingTextBoxFlag xmlns:ma14="http://schemas.microsoft.com/office/mac/drawingml/2011/main" xmlns="" val="0"/>
+              <ma14:wrappingTextBoxFlag xmlns="" xmlns:ma14="http://schemas.microsoft.com/office/mac/drawingml/2011/main" val="0"/>
             </a:ext>
           </a:extLst>
         </p:spPr>
@@ -3195,7 +3195,7 @@
           </a:prstGeom>
           <a:extLst>
             <a:ext uri="{C572A759-6A51-4108-AA02-DFA0A04FC94B}">
-              <ma14:wrappingTextBoxFlag xmlns:ma14="http://schemas.microsoft.com/office/mac/drawingml/2011/main" xmlns="" val="0"/>
+              <ma14:wrappingTextBoxFlag xmlns="" xmlns:ma14="http://schemas.microsoft.com/office/mac/drawingml/2011/main" val="0"/>
             </a:ext>
           </a:extLst>
         </p:spPr>
@@ -3790,7 +3790,7 @@
           </a:prstGeom>
           <a:extLst>
             <a:ext uri="{C572A759-6A51-4108-AA02-DFA0A04FC94B}">
-              <ma14:wrappingTextBoxFlag xmlns:ma14="http://schemas.microsoft.com/office/mac/drawingml/2011/main" xmlns="" val="0"/>
+              <ma14:wrappingTextBoxFlag xmlns="" xmlns:ma14="http://schemas.microsoft.com/office/mac/drawingml/2011/main" val="0"/>
             </a:ext>
           </a:extLst>
         </p:spPr>
@@ -3921,9 +3921,116 @@
           </a:p>
         </p:txBody>
       </p:sp>
+      <p:sp>
+        <p:nvSpPr>
+          <p:cNvPr id="5" name="Text 2"/>
+          <p:cNvSpPr/>
+          <p:nvPr/>
+        </p:nvSpPr>
+        <p:spPr>
+          <a:xfrm>
+            <a:off x="6400800" y="1051560"/>
+            <a:ext cx="2377440" cy="3474720"/>
+          </a:xfrm>
+          <a:prstGeom prst="rect">
+            <a:avLst/>
+          </a:prstGeom>
+          <a:noFill/>
+          <a:ln/>
+        </p:spPr>
+        <p:txBody>
+          <a:bodyPr wrap="square" lIns="0" tIns="0" rIns="0" bIns="0" rtlCol="0" anchor="ctr"/>
+          <a:lstStyle/>
+          <a:p>
+            <a:pPr marL="0" indent="0">
+              <a:buNone/>
+            </a:pPr>
+            <a:r>
+              <a:rPr lang="en-US" sz="1100" b="1" dirty="0">
+                <a:solidFill>
+                  <a:srgbClr val="0F4C8A"/>
+                </a:solidFill>
+                <a:latin typeface="Calibri" pitchFamily="34" charset="0"/>
+                <a:ea typeface="Calibri" pitchFamily="34" charset="-122"/>
+                <a:cs typeface="Calibri" pitchFamily="34" charset="-120"/>
+              </a:rPr>
+              <a:t>What to notice
+</a:t>
+            </a:r>
+            <a:r>
+              <a:rPr lang="en-US" sz="1100" dirty="0">
+                <a:solidFill>
+                  <a:srgbClr val="2A2A2A"/>
+                </a:solidFill>
+                <a:latin typeface="Calibri" pitchFamily="34" charset="0"/>
+                <a:ea typeface="Calibri" pitchFamily="34" charset="-122"/>
+                <a:cs typeface="Calibri" pitchFamily="34" charset="-120"/>
+              </a:rPr>
+              <a:t>• Commuter cluster dominates peripheral bike corridors.
+• Hotspot cluster concentrates in the CBD and along the Limmat.
+• Outlier stations stand out — often night-time or sparse sites.</a:t>
+            </a:r>
+            <a:endParaRPr lang="en-US" sz="1100" dirty="0"/>
+          </a:p>
+        </p:txBody>
+      </p:sp>
+      <p:sp>
+        <p:nvSpPr>
+          <p:cNvPr id="25" name="Slide Number Placeholder 0"/>
+          <p:cNvSpPr>
+            <a:spLocks noGrp="1"/>
+          </p:cNvSpPr>
+          <p:nvPr>
+            <p:ph type="sldNum" sz="quarter" idx="4294967295"/>
+          </p:nvPr>
+        </p:nvSpPr>
+        <p:spPr>
+          <a:xfrm>
+            <a:off x="8503920" y="4873752"/>
+            <a:ext cx="274320" cy="228600"/>
+          </a:xfrm>
+          <a:prstGeom prst="rect">
+            <a:avLst/>
+          </a:prstGeom>
+          <a:extLst>
+            <a:ext uri="{C572A759-6A51-4108-AA02-DFA0A04FC94B}">
+              <ma14:wrappingTextBoxFlag xmlns="" xmlns:ma14="http://schemas.microsoft.com/office/mac/drawingml/2011/main" val="0"/>
+            </a:ext>
+          </a:extLst>
+        </p:spPr>
+        <p:txBody>
+          <a:bodyPr/>
+          <a:lstStyle>
+            <a:lvl1pPr>
+              <a:defRPr sz="900">
+                <a:solidFill>
+                  <a:srgbClr val="5A6773"/>
+                </a:solidFill>
+                <a:latin typeface="Calibri"/>
+                <a:ea typeface="Calibri"/>
+                <a:cs typeface="Calibri"/>
+              </a:defRPr>
+            </a:lvl1pPr>
+          </a:lstStyle>
+          <a:p>
+            <a:pPr algn="r"/>
+            <a:fld id="{F7021451-1387-4CA6-816F-3879F97B5CBC}" type="slidenum">
+              <a:rPr lang="en-US" b="0"/>
+              <a:t>12</a:t>
+            </a:fld>
+            <a:endParaRPr lang="en-US"/>
+          </a:p>
+        </p:txBody>
+      </p:sp>
       <p:pic>
         <p:nvPicPr>
-          <p:cNvPr id="4" name="Image 0" descr="/sessions/intelligent-blissful-shannon/slide_assets/cluster_map.png"/>
+          <p:cNvPr id="7" name="Grafik 6">
+            <a:extLst>
+              <a:ext uri="{FF2B5EF4-FFF2-40B4-BE49-F238E27FC236}">
+                <a16:creationId xmlns:a16="http://schemas.microsoft.com/office/drawing/2014/main" id="{B2B1F2A5-A72C-7C8E-24EF-D2E500612F7B}"/>
+              </a:ext>
+            </a:extLst>
+          </p:cNvPr>
           <p:cNvPicPr>
             <a:picLocks noChangeAspect="1"/>
           </p:cNvPicPr>
@@ -3937,115 +4044,14 @@
         </p:blipFill>
         <p:spPr>
           <a:xfrm>
-            <a:off x="365760" y="1005840"/>
-            <a:ext cx="5852160" cy="3566160"/>
+            <a:off x="425416" y="1168481"/>
+            <a:ext cx="5224894" cy="3472099"/>
           </a:xfrm>
           <a:prstGeom prst="rect">
             <a:avLst/>
           </a:prstGeom>
         </p:spPr>
       </p:pic>
-      <p:sp>
-        <p:nvSpPr>
-          <p:cNvPr id="5" name="Text 2"/>
-          <p:cNvSpPr/>
-          <p:nvPr/>
-        </p:nvSpPr>
-        <p:spPr>
-          <a:xfrm>
-            <a:off x="6400800" y="1051560"/>
-            <a:ext cx="2377440" cy="3474720"/>
-          </a:xfrm>
-          <a:prstGeom prst="rect">
-            <a:avLst/>
-          </a:prstGeom>
-          <a:noFill/>
-          <a:ln/>
-        </p:spPr>
-        <p:txBody>
-          <a:bodyPr wrap="square" lIns="0" tIns="0" rIns="0" bIns="0" rtlCol="0" anchor="ctr"/>
-          <a:lstStyle/>
-          <a:p>
-            <a:pPr marL="0" indent="0">
-              <a:buNone/>
-            </a:pPr>
-            <a:r>
-              <a:rPr lang="en-US" sz="1100" b="1" dirty="0">
-                <a:solidFill>
-                  <a:srgbClr val="0F4C8A"/>
-                </a:solidFill>
-                <a:latin typeface="Calibri" pitchFamily="34" charset="0"/>
-                <a:ea typeface="Calibri" pitchFamily="34" charset="-122"/>
-                <a:cs typeface="Calibri" pitchFamily="34" charset="-120"/>
-              </a:rPr>
-              <a:t>What to notice
-</a:t>
-            </a:r>
-            <a:r>
-              <a:rPr lang="en-US" sz="1100" dirty="0">
-                <a:solidFill>
-                  <a:srgbClr val="2A2A2A"/>
-                </a:solidFill>
-                <a:latin typeface="Calibri" pitchFamily="34" charset="0"/>
-                <a:ea typeface="Calibri" pitchFamily="34" charset="-122"/>
-                <a:cs typeface="Calibri" pitchFamily="34" charset="-120"/>
-              </a:rPr>
-              <a:t>• Commuter cluster dominates peripheral bike corridors.
-• Hotspot cluster concentrates in the CBD and along the Limmat.
-• Outlier stations stand out — often night-time or sparse sites.</a:t>
-            </a:r>
-            <a:endParaRPr lang="en-US" sz="1100" dirty="0"/>
-          </a:p>
-        </p:txBody>
-      </p:sp>
-      <p:sp>
-        <p:nvSpPr>
-          <p:cNvPr id="25" name="Slide Number Placeholder 0"/>
-          <p:cNvSpPr>
-            <a:spLocks noGrp="1"/>
-          </p:cNvSpPr>
-          <p:nvPr>
-            <p:ph type="sldNum" sz="quarter" idx="4294967295"/>
-          </p:nvPr>
-        </p:nvSpPr>
-        <p:spPr>
-          <a:xfrm>
-            <a:off x="8503920" y="4873752"/>
-            <a:ext cx="274320" cy="228600"/>
-          </a:xfrm>
-          <a:prstGeom prst="rect">
-            <a:avLst/>
-          </a:prstGeom>
-          <a:extLst>
-            <a:ext uri="{C572A759-6A51-4108-AA02-DFA0A04FC94B}">
-              <ma14:wrappingTextBoxFlag xmlns:ma14="http://schemas.microsoft.com/office/mac/drawingml/2011/main" xmlns="" val="0"/>
-            </a:ext>
-          </a:extLst>
-        </p:spPr>
-        <p:txBody>
-          <a:bodyPr/>
-          <a:lstStyle>
-            <a:lvl1pPr>
-              <a:defRPr sz="900">
-                <a:solidFill>
-                  <a:srgbClr val="5A6773"/>
-                </a:solidFill>
-                <a:latin typeface="Calibri"/>
-                <a:ea typeface="Calibri"/>
-                <a:cs typeface="Calibri"/>
-              </a:defRPr>
-            </a:lvl1pPr>
-          </a:lstStyle>
-          <a:p>
-            <a:pPr algn="r"/>
-            <a:fld id="{F7021451-1387-4CA6-816F-3879F97B5CBC}" type="slidenum">
-              <a:rPr lang="en-US" b="0"/>
-              <a:t>12</a:t>
-            </a:fld>
-            <a:endParaRPr lang="en-US"/>
-          </a:p>
-        </p:txBody>
-      </p:sp>
     </p:spTree>
   </p:cSld>
   <p:clrMapOvr>
@@ -4458,7 +4464,7 @@
           </a:prstGeom>
           <a:extLst>
             <a:ext uri="{C572A759-6A51-4108-AA02-DFA0A04FC94B}">
-              <ma14:wrappingTextBoxFlag xmlns:ma14="http://schemas.microsoft.com/office/mac/drawingml/2011/main" xmlns="" val="0"/>
+              <ma14:wrappingTextBoxFlag xmlns="" xmlns:ma14="http://schemas.microsoft.com/office/mac/drawingml/2011/main" val="0"/>
             </a:ext>
           </a:extLst>
         </p:spPr>
@@ -5279,7 +5285,7 @@
           </a:prstGeom>
           <a:extLst>
             <a:ext uri="{C572A759-6A51-4108-AA02-DFA0A04FC94B}">
-              <ma14:wrappingTextBoxFlag xmlns:ma14="http://schemas.microsoft.com/office/mac/drawingml/2011/main" xmlns="" val="0"/>
+              <ma14:wrappingTextBoxFlag xmlns="" xmlns:ma14="http://schemas.microsoft.com/office/mac/drawingml/2011/main" val="0"/>
             </a:ext>
           </a:extLst>
         </p:spPr>
@@ -5673,7 +5679,7 @@
           </a:prstGeom>
           <a:extLst>
             <a:ext uri="{C572A759-6A51-4108-AA02-DFA0A04FC94B}">
-              <ma14:wrappingTextBoxFlag xmlns:ma14="http://schemas.microsoft.com/office/mac/drawingml/2011/main" xmlns="" val="0"/>
+              <ma14:wrappingTextBoxFlag xmlns="" xmlns:ma14="http://schemas.microsoft.com/office/mac/drawingml/2011/main" val="0"/>
             </a:ext>
           </a:extLst>
         </p:spPr>
@@ -6372,7 +6378,7 @@
           </a:prstGeom>
           <a:extLst>
             <a:ext uri="{C572A759-6A51-4108-AA02-DFA0A04FC94B}">
-              <ma14:wrappingTextBoxFlag xmlns:ma14="http://schemas.microsoft.com/office/mac/drawingml/2011/main" xmlns="" val="0"/>
+              <ma14:wrappingTextBoxFlag xmlns="" xmlns:ma14="http://schemas.microsoft.com/office/mac/drawingml/2011/main" val="0"/>
             </a:ext>
           </a:extLst>
         </p:spPr>
@@ -6622,7 +6628,7 @@
           </a:prstGeom>
           <a:extLst>
             <a:ext uri="{C572A759-6A51-4108-AA02-DFA0A04FC94B}">
-              <ma14:wrappingTextBoxFlag xmlns:ma14="http://schemas.microsoft.com/office/mac/drawingml/2011/main" xmlns="" val="0"/>
+              <ma14:wrappingTextBoxFlag xmlns="" xmlns:ma14="http://schemas.microsoft.com/office/mac/drawingml/2011/main" val="0"/>
             </a:ext>
           </a:extLst>
         </p:spPr>
@@ -7493,7 +7499,7 @@
           </a:prstGeom>
           <a:extLst>
             <a:ext uri="{C572A759-6A51-4108-AA02-DFA0A04FC94B}">
-              <ma14:wrappingTextBoxFlag xmlns:ma14="http://schemas.microsoft.com/office/mac/drawingml/2011/main" xmlns="" val="0"/>
+              <ma14:wrappingTextBoxFlag xmlns="" xmlns:ma14="http://schemas.microsoft.com/office/mac/drawingml/2011/main" val="0"/>
             </a:ext>
           </a:extLst>
         </p:spPr>
@@ -8095,7 +8101,7 @@
           </a:prstGeom>
           <a:extLst>
             <a:ext uri="{C572A759-6A51-4108-AA02-DFA0A04FC94B}">
-              <ma14:wrappingTextBoxFlag xmlns:ma14="http://schemas.microsoft.com/office/mac/drawingml/2011/main" xmlns="" val="0"/>
+              <ma14:wrappingTextBoxFlag xmlns="" xmlns:ma14="http://schemas.microsoft.com/office/mac/drawingml/2011/main" val="0"/>
             </a:ext>
           </a:extLst>
         </p:spPr>
@@ -8771,7 +8777,7 @@
           </a:prstGeom>
           <a:extLst>
             <a:ext uri="{C572A759-6A51-4108-AA02-DFA0A04FC94B}">
-              <ma14:wrappingTextBoxFlag xmlns:ma14="http://schemas.microsoft.com/office/mac/drawingml/2011/main" xmlns="" val="0"/>
+              <ma14:wrappingTextBoxFlag xmlns="" xmlns:ma14="http://schemas.microsoft.com/office/mac/drawingml/2011/main" val="0"/>
             </a:ext>
           </a:extLst>
         </p:spPr>
@@ -9646,7 +9652,7 @@
           </a:prstGeom>
           <a:extLst>
             <a:ext uri="{C572A759-6A51-4108-AA02-DFA0A04FC94B}">
-              <ma14:wrappingTextBoxFlag xmlns:ma14="http://schemas.microsoft.com/office/mac/drawingml/2011/main" xmlns="" val="0"/>
+              <ma14:wrappingTextBoxFlag xmlns="" xmlns:ma14="http://schemas.microsoft.com/office/mac/drawingml/2011/main" val="0"/>
             </a:ext>
           </a:extLst>
         </p:spPr>
@@ -10388,7 +10394,7 @@
           </a:prstGeom>
           <a:extLst>
             <a:ext uri="{C572A759-6A51-4108-AA02-DFA0A04FC94B}">
-              <ma14:wrappingTextBoxFlag xmlns:ma14="http://schemas.microsoft.com/office/mac/drawingml/2011/main" xmlns="" val="0"/>
+              <ma14:wrappingTextBoxFlag xmlns="" xmlns:ma14="http://schemas.microsoft.com/office/mac/drawingml/2011/main" val="0"/>
             </a:ext>
           </a:extLst>
         </p:spPr>
@@ -10519,9 +10525,103 @@
           </a:p>
         </p:txBody>
       </p:sp>
+      <p:sp>
+        <p:nvSpPr>
+          <p:cNvPr id="5" name="Text 2"/>
+          <p:cNvSpPr/>
+          <p:nvPr/>
+        </p:nvSpPr>
+        <p:spPr>
+          <a:xfrm>
+            <a:off x="6400800" y="1051560"/>
+            <a:ext cx="2377440" cy="3474720"/>
+          </a:xfrm>
+          <a:prstGeom prst="rect">
+            <a:avLst/>
+          </a:prstGeom>
+          <a:noFill/>
+          <a:ln/>
+        </p:spPr>
+        <p:txBody>
+          <a:bodyPr wrap="square" lIns="0" tIns="0" rIns="0" bIns="0" rtlCol="0" anchor="ctr"/>
+          <a:lstStyle/>
+          <a:p>
+            <a:pPr marL="0" indent="0">
+              <a:buNone/>
+            </a:pPr>
+            <a:r>
+              <a:rPr lang="en-US" sz="1200" dirty="0">
+                <a:solidFill>
+                  <a:srgbClr val="2A2A2A"/>
+                </a:solidFill>
+                <a:latin typeface="Calibri" pitchFamily="34" charset="0"/>
+                <a:ea typeface="Calibri" pitchFamily="34" charset="-122"/>
+                <a:cs typeface="Calibri" pitchFamily="34" charset="-120"/>
+              </a:rPr>
+              <a:t>Concentration in the city centre (Limmat axis, Bahnhofstrasse area) and sparser coverage in residential districts.
+Most sensors count bikes in both directions; a subset (~6) is pedestrian-only.</a:t>
+            </a:r>
+            <a:endParaRPr lang="en-US" sz="1200" dirty="0"/>
+          </a:p>
+        </p:txBody>
+      </p:sp>
+      <p:sp>
+        <p:nvSpPr>
+          <p:cNvPr id="25" name="Slide Number Placeholder 0"/>
+          <p:cNvSpPr>
+            <a:spLocks noGrp="1"/>
+          </p:cNvSpPr>
+          <p:nvPr>
+            <p:ph type="sldNum" sz="quarter" idx="4294967295"/>
+          </p:nvPr>
+        </p:nvSpPr>
+        <p:spPr>
+          <a:xfrm>
+            <a:off x="8503920" y="4873752"/>
+            <a:ext cx="274320" cy="228600"/>
+          </a:xfrm>
+          <a:prstGeom prst="rect">
+            <a:avLst/>
+          </a:prstGeom>
+          <a:extLst>
+            <a:ext uri="{C572A759-6A51-4108-AA02-DFA0A04FC94B}">
+              <ma14:wrappingTextBoxFlag xmlns="" xmlns:ma14="http://schemas.microsoft.com/office/mac/drawingml/2011/main" val="0"/>
+            </a:ext>
+          </a:extLst>
+        </p:spPr>
+        <p:txBody>
+          <a:bodyPr/>
+          <a:lstStyle>
+            <a:lvl1pPr>
+              <a:defRPr sz="900">
+                <a:solidFill>
+                  <a:srgbClr val="5A6773"/>
+                </a:solidFill>
+                <a:latin typeface="Calibri"/>
+                <a:ea typeface="Calibri"/>
+                <a:cs typeface="Calibri"/>
+              </a:defRPr>
+            </a:lvl1pPr>
+          </a:lstStyle>
+          <a:p>
+            <a:pPr algn="r"/>
+            <a:fld id="{F7021451-1387-4CA6-816F-3879F97B5CBC}" type="slidenum">
+              <a:rPr lang="en-US" b="0"/>
+              <a:t>6</a:t>
+            </a:fld>
+            <a:endParaRPr lang="en-US"/>
+          </a:p>
+        </p:txBody>
+      </p:sp>
       <p:pic>
         <p:nvPicPr>
-          <p:cNvPr id="4" name="Image 0" descr="/sessions/intelligent-blissful-shannon/slide_assets/stations_map.png"/>
+          <p:cNvPr id="6" name="Grafik 5">
+            <a:extLst>
+              <a:ext uri="{FF2B5EF4-FFF2-40B4-BE49-F238E27FC236}">
+                <a16:creationId xmlns:a16="http://schemas.microsoft.com/office/drawing/2014/main" id="{6897D831-9B67-78D1-0DC6-04C97C3500C0}"/>
+              </a:ext>
+            </a:extLst>
+          </p:cNvPr>
           <p:cNvPicPr>
             <a:picLocks noChangeAspect="1"/>
           </p:cNvPicPr>
@@ -10535,102 +10635,14 @@
         </p:blipFill>
         <p:spPr>
           <a:xfrm>
-            <a:off x="365760" y="1005840"/>
-            <a:ext cx="5852160" cy="3566160"/>
+            <a:off x="380429" y="1051560"/>
+            <a:ext cx="5526497" cy="3614376"/>
           </a:xfrm>
           <a:prstGeom prst="rect">
             <a:avLst/>
           </a:prstGeom>
         </p:spPr>
       </p:pic>
-      <p:sp>
-        <p:nvSpPr>
-          <p:cNvPr id="5" name="Text 2"/>
-          <p:cNvSpPr/>
-          <p:nvPr/>
-        </p:nvSpPr>
-        <p:spPr>
-          <a:xfrm>
-            <a:off x="6400800" y="1051560"/>
-            <a:ext cx="2377440" cy="3474720"/>
-          </a:xfrm>
-          <a:prstGeom prst="rect">
-            <a:avLst/>
-          </a:prstGeom>
-          <a:noFill/>
-          <a:ln/>
-        </p:spPr>
-        <p:txBody>
-          <a:bodyPr wrap="square" lIns="0" tIns="0" rIns="0" bIns="0" rtlCol="0" anchor="ctr"/>
-          <a:lstStyle/>
-          <a:p>
-            <a:pPr marL="0" indent="0">
-              <a:buNone/>
-            </a:pPr>
-            <a:r>
-              <a:rPr lang="en-US" sz="1200" dirty="0">
-                <a:solidFill>
-                  <a:srgbClr val="2A2A2A"/>
-                </a:solidFill>
-                <a:latin typeface="Calibri" pitchFamily="34" charset="0"/>
-                <a:ea typeface="Calibri" pitchFamily="34" charset="-122"/>
-                <a:cs typeface="Calibri" pitchFamily="34" charset="-120"/>
-              </a:rPr>
-              <a:t>Concentration in the city centre (Limmat axis, Bahnhofstrasse area) and sparser coverage in residential districts.
-Most sensors count bikes in both directions; a subset (~6) is pedestrian-only.</a:t>
-            </a:r>
-            <a:endParaRPr lang="en-US" sz="1200" dirty="0"/>
-          </a:p>
-        </p:txBody>
-      </p:sp>
-      <p:sp>
-        <p:nvSpPr>
-          <p:cNvPr id="25" name="Slide Number Placeholder 0"/>
-          <p:cNvSpPr>
-            <a:spLocks noGrp="1"/>
-          </p:cNvSpPr>
-          <p:nvPr>
-            <p:ph type="sldNum" sz="quarter" idx="4294967295"/>
-          </p:nvPr>
-        </p:nvSpPr>
-        <p:spPr>
-          <a:xfrm>
-            <a:off x="8503920" y="4873752"/>
-            <a:ext cx="274320" cy="228600"/>
-          </a:xfrm>
-          <a:prstGeom prst="rect">
-            <a:avLst/>
-          </a:prstGeom>
-          <a:extLst>
-            <a:ext uri="{C572A759-6A51-4108-AA02-DFA0A04FC94B}">
-              <ma14:wrappingTextBoxFlag xmlns:ma14="http://schemas.microsoft.com/office/mac/drawingml/2011/main" xmlns="" val="0"/>
-            </a:ext>
-          </a:extLst>
-        </p:spPr>
-        <p:txBody>
-          <a:bodyPr/>
-          <a:lstStyle>
-            <a:lvl1pPr>
-              <a:defRPr sz="900">
-                <a:solidFill>
-                  <a:srgbClr val="5A6773"/>
-                </a:solidFill>
-                <a:latin typeface="Calibri"/>
-                <a:ea typeface="Calibri"/>
-                <a:cs typeface="Calibri"/>
-              </a:defRPr>
-            </a:lvl1pPr>
-          </a:lstStyle>
-          <a:p>
-            <a:pPr algn="r"/>
-            <a:fld id="{F7021451-1387-4CA6-816F-3879F97B5CBC}" type="slidenum">
-              <a:rPr lang="en-US" b="0"/>
-              <a:t>6</a:t>
-            </a:fld>
-            <a:endParaRPr lang="en-US"/>
-          </a:p>
-        </p:txBody>
-      </p:sp>
     </p:spTree>
   </p:cSld>
   <p:clrMapOvr>
@@ -10874,7 +10886,7 @@
           </a:prstGeom>
           <a:extLst>
             <a:ext uri="{C572A759-6A51-4108-AA02-DFA0A04FC94B}">
-              <ma14:wrappingTextBoxFlag xmlns:ma14="http://schemas.microsoft.com/office/mac/drawingml/2011/main" xmlns="" val="0"/>
+              <ma14:wrappingTextBoxFlag xmlns="" xmlns:ma14="http://schemas.microsoft.com/office/mac/drawingml/2011/main" val="0"/>
             </a:ext>
           </a:extLst>
         </p:spPr>
@@ -11190,7 +11202,7 @@
           </a:prstGeom>
           <a:extLst>
             <a:ext uri="{C572A759-6A51-4108-AA02-DFA0A04FC94B}">
-              <ma14:wrappingTextBoxFlag xmlns:ma14="http://schemas.microsoft.com/office/mac/drawingml/2011/main" xmlns="" val="0"/>
+              <ma14:wrappingTextBoxFlag xmlns="" xmlns:ma14="http://schemas.microsoft.com/office/mac/drawingml/2011/main" val="0"/>
             </a:ext>
           </a:extLst>
         </p:spPr>
@@ -11479,7 +11491,7 @@
           </a:prstGeom>
           <a:extLst>
             <a:ext uri="{C572A759-6A51-4108-AA02-DFA0A04FC94B}">
-              <ma14:wrappingTextBoxFlag xmlns:ma14="http://schemas.microsoft.com/office/mac/drawingml/2011/main" xmlns="" val="0"/>
+              <ma14:wrappingTextBoxFlag xmlns="" xmlns:ma14="http://schemas.microsoft.com/office/mac/drawingml/2011/main" val="0"/>
             </a:ext>
           </a:extLst>
         </p:spPr>

</xml_diff>